<commit_message>
Preencher integrantes na entrega do CP1
Seis integrantes com RM na capa do PDF e no slide de apresentacao. O layout do
slide 2 foi reajustado: com seis cartoes na altura anterior a lista passava da
borda inferior.

Turma e a participacao individual de cada um continuam como marcador — o
enunciado exige que cada integrante informe o que fez no projeto, e isso nao da
para inferir.

Co-Authored-By: Claude Opus 5 <noreply@anthropic.com>
</commit_message>
<xml_diff>
--- a/docs/S2-CP1/S2-CP1-Motiva-Tema2-Aula.pptx
+++ b/docs/S2-CP1/S2-CP1-Motiva-Tema2-Aula.pptx
@@ -3754,12 +3754,12 @@
         </p:nvSpPr>
         <p:spPr>
           <a:xfrm>
-            <a:off x="640080" y="1828800"/>
-            <a:ext cx="10881360" cy="713232"/>
+            <a:off x="640080" y="1737360"/>
+            <a:ext cx="10881360" cy="658368"/>
           </a:xfrm>
           <a:prstGeom prst="roundRect">
             <a:avLst>
-              <a:gd name="adj" fmla="val 11538"/>
+              <a:gd name="adj" fmla="val 12500"/>
             </a:avLst>
           </a:prstGeom>
           <a:solidFill>
@@ -3781,7 +3781,7 @@
         </p:nvSpPr>
         <p:spPr>
           <a:xfrm>
-            <a:off x="841248" y="1984248"/>
+            <a:off x="841248" y="1892808"/>
             <a:ext cx="402336" cy="402336"/>
           </a:xfrm>
           <a:prstGeom prst="ellipse">
@@ -3806,7 +3806,7 @@
         </p:nvSpPr>
         <p:spPr>
           <a:xfrm>
-            <a:off x="841248" y="1984248"/>
+            <a:off x="841248" y="1892808"/>
             <a:ext cx="402336" cy="402336"/>
           </a:xfrm>
           <a:prstGeom prst="rect">
@@ -3845,7 +3845,7 @@
         </p:nvSpPr>
         <p:spPr>
           <a:xfrm>
-            <a:off x="1417320" y="1938528"/>
+            <a:off x="1417320" y="1847088"/>
             <a:ext cx="5120640" cy="274320"/>
           </a:xfrm>
           <a:prstGeom prst="rect">
@@ -3870,7 +3870,7 @@
                 <a:ea typeface="Calibri" pitchFamily="34" charset="-122"/>
                 <a:cs typeface="Calibri" pitchFamily="34" charset="-120"/>
               </a:rPr>
-              <a:t>[Integrante 1]   ·   RM [RM]</a:t>
+              <a:t>Bento Donato Garcia   ·   RM 561621</a:t>
             </a:r>
             <a:endParaRPr lang="en-US" sz="1500" dirty="0"/>
           </a:p>
@@ -3884,7 +3884,7 @@
         </p:nvSpPr>
         <p:spPr>
           <a:xfrm>
-            <a:off x="1417320" y="2212848"/>
+            <a:off x="1417320" y="2121408"/>
             <a:ext cx="5120640" cy="256032"/>
           </a:xfrm>
           <a:prstGeom prst="rect">
@@ -3909,7 +3909,7 @@
                 <a:ea typeface="Calibri" pitchFamily="34" charset="-122"/>
                 <a:cs typeface="Calibri" pitchFamily="34" charset="-120"/>
               </a:rPr>
-              <a:t>Bloco 1 — painel web</a:t>
+              <a:t>[participação no projeto]</a:t>
             </a:r>
             <a:endParaRPr lang="en-US" sz="1250" dirty="0"/>
           </a:p>
@@ -3923,12 +3923,12 @@
         </p:nvSpPr>
         <p:spPr>
           <a:xfrm>
-            <a:off x="640080" y="2670048"/>
-            <a:ext cx="10881360" cy="713232"/>
+            <a:off x="640080" y="2505456"/>
+            <a:ext cx="10881360" cy="658368"/>
           </a:xfrm>
           <a:prstGeom prst="roundRect">
             <a:avLst>
-              <a:gd name="adj" fmla="val 11538"/>
+              <a:gd name="adj" fmla="val 12500"/>
             </a:avLst>
           </a:prstGeom>
           <a:solidFill>
@@ -3950,7 +3950,7 @@
         </p:nvSpPr>
         <p:spPr>
           <a:xfrm>
-            <a:off x="841248" y="2825496"/>
+            <a:off x="841248" y="2660904"/>
             <a:ext cx="402336" cy="402336"/>
           </a:xfrm>
           <a:prstGeom prst="ellipse">
@@ -3975,7 +3975,7 @@
         </p:nvSpPr>
         <p:spPr>
           <a:xfrm>
-            <a:off x="841248" y="2825496"/>
+            <a:off x="841248" y="2660904"/>
             <a:ext cx="402336" cy="402336"/>
           </a:xfrm>
           <a:prstGeom prst="rect">
@@ -4014,7 +4014,7 @@
         </p:nvSpPr>
         <p:spPr>
           <a:xfrm>
-            <a:off x="1417320" y="2779776"/>
+            <a:off x="1417320" y="2615184"/>
             <a:ext cx="5120640" cy="274320"/>
           </a:xfrm>
           <a:prstGeom prst="rect">
@@ -4039,7 +4039,7 @@
                 <a:ea typeface="Calibri" pitchFamily="34" charset="-122"/>
                 <a:cs typeface="Calibri" pitchFamily="34" charset="-120"/>
               </a:rPr>
-              <a:t>[Integrante 2]   ·   RM [RM]</a:t>
+              <a:t>Enzo Ribeiro Domingues Piazentin   ·   RM 564216</a:t>
             </a:r>
             <a:endParaRPr lang="en-US" sz="1500" dirty="0"/>
           </a:p>
@@ -4053,7 +4053,7 @@
         </p:nvSpPr>
         <p:spPr>
           <a:xfrm>
-            <a:off x="1417320" y="3054096"/>
+            <a:off x="1417320" y="2889504"/>
             <a:ext cx="5120640" cy="256032"/>
           </a:xfrm>
           <a:prstGeom prst="rect">
@@ -4078,7 +4078,7 @@
                 <a:ea typeface="Calibri" pitchFamily="34" charset="-122"/>
                 <a:cs typeface="Calibri" pitchFamily="34" charset="-120"/>
               </a:rPr>
-              <a:t>Bloco 1 — app mobile</a:t>
+              <a:t>[participação no projeto]</a:t>
             </a:r>
             <a:endParaRPr lang="en-US" sz="1250" dirty="0"/>
           </a:p>
@@ -4092,12 +4092,12 @@
         </p:nvSpPr>
         <p:spPr>
           <a:xfrm>
-            <a:off x="640080" y="3511296"/>
-            <a:ext cx="10881360" cy="713232"/>
+            <a:off x="640080" y="3273552"/>
+            <a:ext cx="10881360" cy="658368"/>
           </a:xfrm>
           <a:prstGeom prst="roundRect">
             <a:avLst>
-              <a:gd name="adj" fmla="val 11538"/>
+              <a:gd name="adj" fmla="val 12500"/>
             </a:avLst>
           </a:prstGeom>
           <a:solidFill>
@@ -4119,7 +4119,7 @@
         </p:nvSpPr>
         <p:spPr>
           <a:xfrm>
-            <a:off x="841248" y="3666744"/>
+            <a:off x="841248" y="3429000"/>
             <a:ext cx="402336" cy="402336"/>
           </a:xfrm>
           <a:prstGeom prst="ellipse">
@@ -4144,7 +4144,7 @@
         </p:nvSpPr>
         <p:spPr>
           <a:xfrm>
-            <a:off x="841248" y="3666744"/>
+            <a:off x="841248" y="3429000"/>
             <a:ext cx="402336" cy="402336"/>
           </a:xfrm>
           <a:prstGeom prst="rect">
@@ -4183,7 +4183,7 @@
         </p:nvSpPr>
         <p:spPr>
           <a:xfrm>
-            <a:off x="1417320" y="3621024"/>
+            <a:off x="1417320" y="3383280"/>
             <a:ext cx="5120640" cy="274320"/>
           </a:xfrm>
           <a:prstGeom prst="rect">
@@ -4208,7 +4208,7 @@
                 <a:ea typeface="Calibri" pitchFamily="34" charset="-122"/>
                 <a:cs typeface="Calibri" pitchFamily="34" charset="-120"/>
               </a:rPr>
-              <a:t>[Integrante 3]   ·   RM [RM]</a:t>
+              <a:t>Guilherme Domingues Califoni   ·   RM 565157</a:t>
             </a:r>
             <a:endParaRPr lang="en-US" sz="1500" dirty="0"/>
           </a:p>
@@ -4222,7 +4222,7 @@
         </p:nvSpPr>
         <p:spPr>
           <a:xfrm>
-            <a:off x="1417320" y="3895344"/>
+            <a:off x="1417320" y="3657600"/>
             <a:ext cx="5120640" cy="256032"/>
           </a:xfrm>
           <a:prstGeom prst="rect">
@@ -4247,7 +4247,7 @@
                 <a:ea typeface="Calibri" pitchFamily="34" charset="-122"/>
                 <a:cs typeface="Calibri" pitchFamily="34" charset="-120"/>
               </a:rPr>
-              <a:t>Bloco 2 — visão computacional</a:t>
+              <a:t>[participação no projeto]</a:t>
             </a:r>
             <a:endParaRPr lang="en-US" sz="1250" dirty="0"/>
           </a:p>
@@ -4261,12 +4261,12 @@
         </p:nvSpPr>
         <p:spPr>
           <a:xfrm>
-            <a:off x="640080" y="4352544"/>
-            <a:ext cx="10881360" cy="713232"/>
+            <a:off x="640080" y="4041648"/>
+            <a:ext cx="10881360" cy="658368"/>
           </a:xfrm>
           <a:prstGeom prst="roundRect">
             <a:avLst>
-              <a:gd name="adj" fmla="val 11538"/>
+              <a:gd name="adj" fmla="val 12500"/>
             </a:avLst>
           </a:prstGeom>
           <a:solidFill>
@@ -4288,7 +4288,7 @@
         </p:nvSpPr>
         <p:spPr>
           <a:xfrm>
-            <a:off x="841248" y="4507992"/>
+            <a:off x="841248" y="4197096"/>
             <a:ext cx="402336" cy="402336"/>
           </a:xfrm>
           <a:prstGeom prst="ellipse">
@@ -4313,7 +4313,7 @@
         </p:nvSpPr>
         <p:spPr>
           <a:xfrm>
-            <a:off x="841248" y="4507992"/>
+            <a:off x="841248" y="4197096"/>
             <a:ext cx="402336" cy="402336"/>
           </a:xfrm>
           <a:prstGeom prst="rect">
@@ -4352,7 +4352,7 @@
         </p:nvSpPr>
         <p:spPr>
           <a:xfrm>
-            <a:off x="1417320" y="4462272"/>
+            <a:off x="1417320" y="4151376"/>
             <a:ext cx="5120640" cy="274320"/>
           </a:xfrm>
           <a:prstGeom prst="rect">
@@ -4377,7 +4377,7 @@
                 <a:ea typeface="Calibri" pitchFamily="34" charset="-122"/>
                 <a:cs typeface="Calibri" pitchFamily="34" charset="-120"/>
               </a:rPr>
-              <a:t>[Integrante 4]   ·   RM [RM]</a:t>
+              <a:t>Antonio Lucas Santana Tavares   ·   RM 565516</a:t>
             </a:r>
             <a:endParaRPr lang="en-US" sz="1500" dirty="0"/>
           </a:p>
@@ -4391,7 +4391,7 @@
         </p:nvSpPr>
         <p:spPr>
           <a:xfrm>
-            <a:off x="1417320" y="4736592"/>
+            <a:off x="1417320" y="4425696"/>
             <a:ext cx="5120640" cy="256032"/>
           </a:xfrm>
           <a:prstGeom prst="rect">
@@ -4416,7 +4416,7 @@
                 <a:ea typeface="Calibri" pitchFamily="34" charset="-122"/>
                 <a:cs typeface="Calibri" pitchFamily="34" charset="-120"/>
               </a:rPr>
-              <a:t>Bloco 3 — banco e pipeline</a:t>
+              <a:t>[participação no projeto]</a:t>
             </a:r>
             <a:endParaRPr lang="en-US" sz="1250" dirty="0"/>
           </a:p>
@@ -4430,12 +4430,12 @@
         </p:nvSpPr>
         <p:spPr>
           <a:xfrm>
-            <a:off x="640080" y="5193792"/>
-            <a:ext cx="10881360" cy="713232"/>
+            <a:off x="640080" y="4809744"/>
+            <a:ext cx="10881360" cy="658368"/>
           </a:xfrm>
           <a:prstGeom prst="roundRect">
             <a:avLst>
-              <a:gd name="adj" fmla="val 11538"/>
+              <a:gd name="adj" fmla="val 12500"/>
             </a:avLst>
           </a:prstGeom>
           <a:solidFill>
@@ -4457,7 +4457,7 @@
         </p:nvSpPr>
         <p:spPr>
           <a:xfrm>
-            <a:off x="841248" y="5349240"/>
+            <a:off x="841248" y="4965192"/>
             <a:ext cx="402336" cy="402336"/>
           </a:xfrm>
           <a:prstGeom prst="ellipse">
@@ -4482,7 +4482,7 @@
         </p:nvSpPr>
         <p:spPr>
           <a:xfrm>
-            <a:off x="841248" y="5349240"/>
+            <a:off x="841248" y="4965192"/>
             <a:ext cx="402336" cy="402336"/>
           </a:xfrm>
           <a:prstGeom prst="rect">
@@ -4521,7 +4521,7 @@
         </p:nvSpPr>
         <p:spPr>
           <a:xfrm>
-            <a:off x="1417320" y="5303520"/>
+            <a:off x="1417320" y="4919472"/>
             <a:ext cx="5120640" cy="274320"/>
           </a:xfrm>
           <a:prstGeom prst="rect">
@@ -4546,7 +4546,7 @@
                 <a:ea typeface="Calibri" pitchFamily="34" charset="-122"/>
                 <a:cs typeface="Calibri" pitchFamily="34" charset="-120"/>
               </a:rPr>
-              <a:t>[Integrante 5]   ·   RM [RM]</a:t>
+              <a:t>Lucas M.   ·   RM 563667</a:t>
             </a:r>
             <a:endParaRPr lang="en-US" sz="1500" dirty="0"/>
           </a:p>
@@ -4560,7 +4560,7 @@
         </p:nvSpPr>
         <p:spPr>
           <a:xfrm>
-            <a:off x="1417320" y="5577840"/>
+            <a:off x="1417320" y="5193792"/>
             <a:ext cx="5120640" cy="256032"/>
           </a:xfrm>
           <a:prstGeom prst="rect">
@@ -4585,7 +4585,176 @@
                 <a:ea typeface="Calibri" pitchFamily="34" charset="-122"/>
                 <a:cs typeface="Calibri" pitchFamily="34" charset="-120"/>
               </a:rPr>
-              <a:t>Bloco 3 — integração</a:t>
+              <a:t>[participação no projeto]</a:t>
+            </a:r>
+            <a:endParaRPr lang="en-US" sz="1250" dirty="0"/>
+          </a:p>
+        </p:txBody>
+      </p:sp>
+      <p:sp>
+        <p:nvSpPr>
+          <p:cNvPr id="29" name="Shape 27"/>
+          <p:cNvSpPr/>
+          <p:nvPr/>
+        </p:nvSpPr>
+        <p:spPr>
+          <a:xfrm>
+            <a:off x="640080" y="5577840"/>
+            <a:ext cx="10881360" cy="658368"/>
+          </a:xfrm>
+          <a:prstGeom prst="roundRect">
+            <a:avLst>
+              <a:gd name="adj" fmla="val 12500"/>
+            </a:avLst>
+          </a:prstGeom>
+          <a:solidFill>
+            <a:srgbClr val="F6F4FA"/>
+          </a:solidFill>
+          <a:ln w="12700">
+            <a:solidFill>
+              <a:srgbClr val="E3DDEE"/>
+            </a:solidFill>
+            <a:prstDash val="solid"/>
+          </a:ln>
+        </p:spPr>
+      </p:sp>
+      <p:sp>
+        <p:nvSpPr>
+          <p:cNvPr id="30" name="Shape 28"/>
+          <p:cNvSpPr/>
+          <p:nvPr/>
+        </p:nvSpPr>
+        <p:spPr>
+          <a:xfrm>
+            <a:off x="841248" y="5733288"/>
+            <a:ext cx="402336" cy="402336"/>
+          </a:xfrm>
+          <a:prstGeom prst="ellipse">
+            <a:avLst/>
+          </a:prstGeom>
+          <a:solidFill>
+            <a:srgbClr val="2E0854"/>
+          </a:solidFill>
+          <a:ln w="12700">
+            <a:solidFill>
+              <a:srgbClr val="2E0854"/>
+            </a:solidFill>
+            <a:prstDash val="solid"/>
+          </a:ln>
+        </p:spPr>
+      </p:sp>
+      <p:sp>
+        <p:nvSpPr>
+          <p:cNvPr id="31" name="Text 29"/>
+          <p:cNvSpPr txBox="1"/>
+          <p:nvPr/>
+        </p:nvSpPr>
+        <p:spPr>
+          <a:xfrm>
+            <a:off x="841248" y="5733288"/>
+            <a:ext cx="402336" cy="402336"/>
+          </a:xfrm>
+          <a:prstGeom prst="rect">
+            <a:avLst/>
+          </a:prstGeom>
+          <a:noFill/>
+          <a:ln/>
+        </p:spPr>
+        <p:txBody>
+          <a:bodyPr wrap="square" lIns="0" tIns="0" rIns="0" bIns="0" rtlCol="0" anchor="ctr"/>
+          <a:lstStyle/>
+          <a:p>
+            <a:pPr algn="ctr" indent="0" marL="0">
+              <a:buNone/>
+            </a:pPr>
+            <a:r>
+              <a:rPr lang="en-US" sz="1500" b="1" dirty="0">
+                <a:solidFill>
+                  <a:srgbClr val="FFFFFF"/>
+                </a:solidFill>
+                <a:latin typeface="Calibri" pitchFamily="34" charset="0"/>
+                <a:ea typeface="Calibri" pitchFamily="34" charset="-122"/>
+                <a:cs typeface="Calibri" pitchFamily="34" charset="-120"/>
+              </a:rPr>
+              <a:t>6</a:t>
+            </a:r>
+            <a:endParaRPr lang="en-US" sz="1500" dirty="0"/>
+          </a:p>
+        </p:txBody>
+      </p:sp>
+      <p:sp>
+        <p:nvSpPr>
+          <p:cNvPr id="32" name="Text 30"/>
+          <p:cNvSpPr txBox="1"/>
+          <p:nvPr/>
+        </p:nvSpPr>
+        <p:spPr>
+          <a:xfrm>
+            <a:off x="1417320" y="5687568"/>
+            <a:ext cx="5120640" cy="274320"/>
+          </a:xfrm>
+          <a:prstGeom prst="rect">
+            <a:avLst/>
+          </a:prstGeom>
+          <a:noFill/>
+          <a:ln/>
+        </p:spPr>
+        <p:txBody>
+          <a:bodyPr wrap="square" lIns="0" tIns="0" rIns="0" bIns="0" rtlCol="0" anchor="ctr"/>
+          <a:lstStyle/>
+          <a:p>
+            <a:pPr indent="0" marL="0">
+              <a:buNone/>
+            </a:pPr>
+            <a:r>
+              <a:rPr lang="en-US" sz="1500" b="1" dirty="0">
+                <a:solidFill>
+                  <a:srgbClr val="201A2B"/>
+                </a:solidFill>
+                <a:latin typeface="Calibri" pitchFamily="34" charset="0"/>
+                <a:ea typeface="Calibri" pitchFamily="34" charset="-122"/>
+                <a:cs typeface="Calibri" pitchFamily="34" charset="-120"/>
+              </a:rPr>
+              <a:t>Gustavo Schimith   ·   RM 564800</a:t>
+            </a:r>
+            <a:endParaRPr lang="en-US" sz="1500" dirty="0"/>
+          </a:p>
+        </p:txBody>
+      </p:sp>
+      <p:sp>
+        <p:nvSpPr>
+          <p:cNvPr id="33" name="Text 31"/>
+          <p:cNvSpPr txBox="1"/>
+          <p:nvPr/>
+        </p:nvSpPr>
+        <p:spPr>
+          <a:xfrm>
+            <a:off x="1417320" y="5961888"/>
+            <a:ext cx="5120640" cy="256032"/>
+          </a:xfrm>
+          <a:prstGeom prst="rect">
+            <a:avLst/>
+          </a:prstGeom>
+          <a:noFill/>
+          <a:ln/>
+        </p:spPr>
+        <p:txBody>
+          <a:bodyPr wrap="square" lIns="0" tIns="0" rIns="0" bIns="0" rtlCol="0" anchor="ctr"/>
+          <a:lstStyle/>
+          <a:p>
+            <a:pPr indent="0" marL="0">
+              <a:buNone/>
+            </a:pPr>
+            <a:r>
+              <a:rPr lang="en-US" sz="1250" dirty="0">
+                <a:solidFill>
+                  <a:srgbClr val="675E78"/>
+                </a:solidFill>
+                <a:latin typeface="Calibri" pitchFamily="34" charset="0"/>
+                <a:ea typeface="Calibri" pitchFamily="34" charset="-122"/>
+                <a:cs typeface="Calibri" pitchFamily="34" charset="-120"/>
+              </a:rPr>
+              <a:t>[participação no projeto]</a:t>
             </a:r>
             <a:endParaRPr lang="en-US" sz="1250" dirty="0"/>
           </a:p>

</xml_diff>